<commit_message>
ERC PPT: erc_30min.html의 실제 Plotly 차트 13개를 playwright로 캡처하여 PPT에 삽입 (총 27개 이미지)
</commit_message>
<xml_diff>
--- a/erc-presentation/erc_30min_bw.pptx
+++ b/erc-presentation/erc_30min_bw.pptx
@@ -5876,7 +5876,7 @@
       </p:sp>
       <p:pic>
         <p:nvPicPr>
-          <p:cNvPr id="16" name="Picture 15" descr="chart_4asset.png"/>
+          <p:cNvPr id="16" name="Picture 15" descr="driven_4asset_weights.png"/>
           <p:cNvPicPr>
             <a:picLocks noChangeAspect="1"/>
           </p:cNvPicPr>
@@ -5891,16 +5891,40 @@
         <p:spPr>
           <a:xfrm>
             <a:off x="548640" y="5303520"/>
-            <a:ext cx="10972800" cy="1371600"/>
+            <a:ext cx="5486400" cy="1371600"/>
           </a:xfrm>
           <a:prstGeom prst="rect">
             <a:avLst/>
           </a:prstGeom>
         </p:spPr>
       </p:pic>
-      <p:sp>
-        <p:nvSpPr>
-          <p:cNvPr id="17" name="TextBox 16"/>
+      <p:pic>
+        <p:nvPicPr>
+          <p:cNvPr id="17" name="Picture 16" descr="driven_4asset_rc.png"/>
+          <p:cNvPicPr>
+            <a:picLocks noChangeAspect="1"/>
+          </p:cNvPicPr>
+          <p:nvPr/>
+        </p:nvPicPr>
+        <p:blipFill>
+          <a:blip r:embed="rId3"/>
+          <a:stretch>
+            <a:fillRect/>
+          </a:stretch>
+        </p:blipFill>
+        <p:spPr>
+          <a:xfrm>
+            <a:off x="6217920" y="5303520"/>
+            <a:ext cx="5486400" cy="1371600"/>
+          </a:xfrm>
+          <a:prstGeom prst="rect">
+            <a:avLst/>
+          </a:prstGeom>
+        </p:spPr>
+      </p:pic>
+      <p:sp>
+        <p:nvSpPr>
+          <p:cNvPr id="18" name="TextBox 17"/>
           <p:cNvSpPr txBox="1"/>
           <p:nvPr/>
         </p:nvSpPr>
@@ -10745,7 +10769,7 @@
       </p:sp>
       <p:pic>
         <p:nvPicPr>
-          <p:cNvPr id="8" name="Picture 7" descr="chart_box_weights.png"/>
+          <p:cNvPr id="8" name="Picture 7" descr="driven_box_w_erc.png"/>
           <p:cNvPicPr>
             <a:picLocks noChangeAspect="1"/>
           </p:cNvPicPr>
@@ -10769,7 +10793,7 @@
       </p:pic>
       <p:pic>
         <p:nvPicPr>
-          <p:cNvPr id="9" name="Picture 8" descr="chart_box_rc.png"/>
+          <p:cNvPr id="9" name="Picture 8" descr="driven_box_rc_erc.png"/>
           <p:cNvPicPr>
             <a:picLocks noChangeAspect="1"/>
           </p:cNvPicPr>
@@ -10791,9 +10815,153 @@
           </a:prstGeom>
         </p:spPr>
       </p:pic>
-      <p:sp>
-        <p:nvSpPr>
-          <p:cNvPr id="10" name="TextBox 9"/>
+      <p:pic>
+        <p:nvPicPr>
+          <p:cNvPr id="10" name="Picture 9" descr="driven_box_w_ew.png"/>
+          <p:cNvPicPr>
+            <a:picLocks noChangeAspect="1"/>
+          </p:cNvPicPr>
+          <p:nvPr/>
+        </p:nvPicPr>
+        <p:blipFill>
+          <a:blip r:embed="rId6"/>
+          <a:stretch>
+            <a:fillRect/>
+          </a:stretch>
+        </p:blipFill>
+        <p:spPr>
+          <a:xfrm>
+            <a:off x="6217920" y="3474720"/>
+            <a:ext cx="1737360" cy="1371600"/>
+          </a:xfrm>
+          <a:prstGeom prst="rect">
+            <a:avLst/>
+          </a:prstGeom>
+        </p:spPr>
+      </p:pic>
+      <p:pic>
+        <p:nvPicPr>
+          <p:cNvPr id="11" name="Picture 10" descr="driven_box_w_mv.png"/>
+          <p:cNvPicPr>
+            <a:picLocks noChangeAspect="1"/>
+          </p:cNvPicPr>
+          <p:nvPr/>
+        </p:nvPicPr>
+        <p:blipFill>
+          <a:blip r:embed="rId7"/>
+          <a:stretch>
+            <a:fillRect/>
+          </a:stretch>
+        </p:blipFill>
+        <p:spPr>
+          <a:xfrm>
+            <a:off x="7955279" y="3474720"/>
+            <a:ext cx="1737360" cy="1371600"/>
+          </a:xfrm>
+          <a:prstGeom prst="rect">
+            <a:avLst/>
+          </a:prstGeom>
+        </p:spPr>
+      </p:pic>
+      <p:pic>
+        <p:nvPicPr>
+          <p:cNvPr id="12" name="Picture 11" descr="driven_box_w_erc.png"/>
+          <p:cNvPicPr>
+            <a:picLocks noChangeAspect="1"/>
+          </p:cNvPicPr>
+          <p:nvPr/>
+        </p:nvPicPr>
+        <p:blipFill>
+          <a:blip r:embed="rId4"/>
+          <a:stretch>
+            <a:fillRect/>
+          </a:stretch>
+        </p:blipFill>
+        <p:spPr>
+          <a:xfrm>
+            <a:off x="9692640" y="3474720"/>
+            <a:ext cx="1737360" cy="1371600"/>
+          </a:xfrm>
+          <a:prstGeom prst="rect">
+            <a:avLst/>
+          </a:prstGeom>
+        </p:spPr>
+      </p:pic>
+      <p:pic>
+        <p:nvPicPr>
+          <p:cNvPr id="13" name="Picture 12" descr="driven_box_rc_ew.png"/>
+          <p:cNvPicPr>
+            <a:picLocks noChangeAspect="1"/>
+          </p:cNvPicPr>
+          <p:nvPr/>
+        </p:nvPicPr>
+        <p:blipFill>
+          <a:blip r:embed="rId8"/>
+          <a:stretch>
+            <a:fillRect/>
+          </a:stretch>
+        </p:blipFill>
+        <p:spPr>
+          <a:xfrm>
+            <a:off x="6217920" y="4937760"/>
+            <a:ext cx="1737360" cy="1371600"/>
+          </a:xfrm>
+          <a:prstGeom prst="rect">
+            <a:avLst/>
+          </a:prstGeom>
+        </p:spPr>
+      </p:pic>
+      <p:pic>
+        <p:nvPicPr>
+          <p:cNvPr id="14" name="Picture 13" descr="driven_box_rc_mv.png"/>
+          <p:cNvPicPr>
+            <a:picLocks noChangeAspect="1"/>
+          </p:cNvPicPr>
+          <p:nvPr/>
+        </p:nvPicPr>
+        <p:blipFill>
+          <a:blip r:embed="rId9"/>
+          <a:stretch>
+            <a:fillRect/>
+          </a:stretch>
+        </p:blipFill>
+        <p:spPr>
+          <a:xfrm>
+            <a:off x="7955279" y="4937760"/>
+            <a:ext cx="1737360" cy="1371600"/>
+          </a:xfrm>
+          <a:prstGeom prst="rect">
+            <a:avLst/>
+          </a:prstGeom>
+        </p:spPr>
+      </p:pic>
+      <p:pic>
+        <p:nvPicPr>
+          <p:cNvPr id="15" name="Picture 14" descr="driven_box_rc_erc.png"/>
+          <p:cNvPicPr>
+            <a:picLocks noChangeAspect="1"/>
+          </p:cNvPicPr>
+          <p:nvPr/>
+        </p:nvPicPr>
+        <p:blipFill>
+          <a:blip r:embed="rId5"/>
+          <a:stretch>
+            <a:fillRect/>
+          </a:stretch>
+        </p:blipFill>
+        <p:spPr>
+          <a:xfrm>
+            <a:off x="9692640" y="4937760"/>
+            <a:ext cx="1737360" cy="1371600"/>
+          </a:xfrm>
+          <a:prstGeom prst="rect">
+            <a:avLst/>
+          </a:prstGeom>
+        </p:spPr>
+      </p:pic>
+      <p:sp>
+        <p:nvSpPr>
+          <p:cNvPr id="16" name="TextBox 15"/>
           <p:cNvSpPr txBox="1"/>
           <p:nvPr/>
         </p:nvSpPr>
@@ -11796,7 +11964,7 @@
       </p:pic>
       <p:pic>
         <p:nvPicPr>
-          <p:cNvPr id="6" name="Picture 5" descr="chart_cumret.png"/>
+          <p:cNvPr id="6" name="Picture 5" descr="driven_cumret.png"/>
           <p:cNvPicPr>
             <a:picLocks noChangeAspect="1"/>
           </p:cNvPicPr>
@@ -13556,7 +13724,7 @@
       </p:sp>
       <p:pic>
         <p:nvPicPr>
-          <p:cNvPr id="8" name="Picture 7" descr="chart_weight_ts.png"/>
+          <p:cNvPr id="8" name="Picture 7" descr="driven_weight_ts.png"/>
           <p:cNvPicPr>
             <a:picLocks noChangeAspect="1"/>
           </p:cNvPicPr>
@@ -13580,7 +13748,7 @@
       </p:pic>
       <p:pic>
         <p:nvPicPr>
-          <p:cNvPr id="9" name="Picture 8" descr="chart_rc_ts.png"/>
+          <p:cNvPr id="9" name="Picture 8" descr="driven_rc_ts.png"/>
           <p:cNvPicPr>
             <a:picLocks noChangeAspect="1"/>
           </p:cNvPicPr>
@@ -15352,9 +15520,33 @@
           </a:p>
         </p:txBody>
       </p:sp>
-      <p:sp>
-        <p:nvSpPr>
-          <p:cNvPr id="5" name="TextBox 4"/>
+      <p:pic>
+        <p:nvPicPr>
+          <p:cNvPr id="5" name="Picture 4" descr="driven_radar.png"/>
+          <p:cNvPicPr>
+            <a:picLocks noChangeAspect="1"/>
+          </p:cNvPicPr>
+          <p:nvPr/>
+        </p:nvPicPr>
+        <p:blipFill>
+          <a:blip r:embed="rId2"/>
+          <a:stretch>
+            <a:fillRect/>
+          </a:stretch>
+        </p:blipFill>
+        <p:spPr>
+          <a:xfrm>
+            <a:off x="7772400" y="1371600"/>
+            <a:ext cx="4114800" cy="4114800"/>
+          </a:xfrm>
+          <a:prstGeom prst="rect">
+            <a:avLst/>
+          </a:prstGeom>
+        </p:spPr>
+      </p:pic>
+      <p:sp>
+        <p:nvSpPr>
+          <p:cNvPr id="6" name="TextBox 5"/>
           <p:cNvSpPr txBox="1"/>
           <p:nvPr/>
         </p:nvSpPr>
@@ -17723,7 +17915,7 @@
       </p:sp>
       <p:pic>
         <p:nvPicPr>
-          <p:cNvPr id="9" name="Picture 8" descr="chart_2asset.png"/>
+          <p:cNvPr id="9" name="Picture 8" descr="driven_2asset.png"/>
           <p:cNvPicPr>
             <a:picLocks noChangeAspect="1"/>
           </p:cNvPicPr>

</xml_diff>